<commit_message>
Update milestones slide to reflect completed EDA
Phase 1 marked done (cohort, cart→purchase, item/category EDA and
exploratory clustering). Phase 2 refocused on temporal split and
purchase-only baselines; risks annotated with EDA mitigations.

Co-authored-by: leeshirley2002 <leeshirley2002@users.noreply.github.com>
</commit_message>
<xml_diff>
--- a/presentation/Milestones_and_Risks_Slide.pptx
+++ b/presentation/Milestones_and_Risks_Slide.pptx
@@ -3225,8 +3225,8 @@
         </p:nvSpPr>
         <p:spPr>
           <a:xfrm>
-            <a:off x="365760" y="182880"/>
-            <a:ext cx="11430000" cy="411480"/>
+            <a:off x="365760" y="164592"/>
+            <a:ext cx="11430000" cy="365760"/>
           </a:xfrm>
           <a:prstGeom prst="rect">
             <a:avLst/>
@@ -3241,13 +3241,13 @@
           <a:p>
             <a:pPr algn="l"/>
             <a:r>
-              <a:rPr sz="2800" b="1">
+              <a:rPr sz="2600" b="1">
                 <a:solidFill>
                   <a:srgbClr val="FFFFFF"/>
                 </a:solidFill>
                 <a:latin typeface="Calibri"/>
               </a:rPr>
-              <a:t>Milestones &amp; Risks</a:t>
+              <a:t>Milestones &amp; Risks  (updated for completed EDA)</a:t>
             </a:r>
           </a:p>
         </p:txBody>
@@ -3260,7 +3260,7 @@
         </p:nvSpPr>
         <p:spPr>
           <a:xfrm>
-            <a:off x="365760" y="594360"/>
+            <a:off x="365760" y="566928"/>
             <a:ext cx="11430000" cy="274320"/>
           </a:xfrm>
           <a:prstGeom prst="rect">
@@ -3276,13 +3276,13 @@
           <a:p>
             <a:pPr algn="l"/>
             <a:r>
-              <a:rPr sz="1300" b="0">
+              <a:rPr sz="1200" b="0">
                 <a:solidFill>
                   <a:srgbClr val="B8CBD4"/>
                 </a:solidFill>
                 <a:latin typeface="Calibri"/>
               </a:rPr>
-              <a:t>8-week plan across 4 phases  ·  DS5500 Behavior-Aware Sequential Recommendation</a:t>
+              <a:t>Phase 1 done  ·  Phase 2 next: purchase-only baselines + temporal eval  ·  DS5500 RecSys</a:t>
             </a:r>
           </a:p>
         </p:txBody>
@@ -3295,7 +3295,7 @@
         </p:nvSpPr>
         <p:spPr>
           <a:xfrm>
-            <a:off x="320040" y="1188720"/>
+            <a:off x="320040" y="1170432"/>
             <a:ext cx="2697480" cy="2606040"/>
           </a:xfrm>
           <a:prstGeom prst="roundRect">
@@ -3340,14 +3340,14 @@
         </p:nvSpPr>
         <p:spPr>
           <a:xfrm>
-            <a:off x="320040" y="1188720"/>
+            <a:off x="320040" y="1170432"/>
             <a:ext cx="2697480" cy="502920"/>
           </a:xfrm>
           <a:prstGeom prst="rect">
             <a:avLst/>
           </a:prstGeom>
           <a:solidFill>
-            <a:srgbClr val="2A6F97"/>
+            <a:srgbClr val="2D6A4F"/>
           </a:solidFill>
           <a:ln>
             <a:noFill/>
@@ -3383,8 +3383,8 @@
         </p:nvSpPr>
         <p:spPr>
           <a:xfrm>
-            <a:off x="457200" y="1261872"/>
-            <a:ext cx="1645920" cy="228600"/>
+            <a:off x="429768" y="1243584"/>
+            <a:ext cx="1737360" cy="228600"/>
           </a:xfrm>
           <a:prstGeom prst="rect">
             <a:avLst/>
@@ -3399,13 +3399,13 @@
           <a:p>
             <a:pPr algn="l"/>
             <a:r>
-              <a:rPr sz="1400" b="1">
+              <a:rPr sz="1300" b="1">
                 <a:solidFill>
                   <a:srgbClr val="FFFFFF"/>
                 </a:solidFill>
                 <a:latin typeface="Calibri"/>
               </a:rPr>
-              <a:t>Phase 1</a:t>
+              <a:t>Phase 1 ✓</a:t>
             </a:r>
           </a:p>
         </p:txBody>
@@ -3418,8 +3418,8 @@
         </p:nvSpPr>
         <p:spPr>
           <a:xfrm>
-            <a:off x="1783080" y="1280160"/>
-            <a:ext cx="1097280" cy="228600"/>
+            <a:off x="1737360" y="1261872"/>
+            <a:ext cx="1143000" cy="228600"/>
           </a:xfrm>
           <a:prstGeom prst="rect">
             <a:avLst/>
@@ -3453,8 +3453,8 @@
         </p:nvSpPr>
         <p:spPr>
           <a:xfrm>
-            <a:off x="457200" y="1783080"/>
-            <a:ext cx="2468880" cy="320040"/>
+            <a:off x="429768" y="1764792"/>
+            <a:ext cx="2514600" cy="365760"/>
           </a:xfrm>
           <a:prstGeom prst="rect">
             <a:avLst/>
@@ -3469,13 +3469,13 @@
           <a:p>
             <a:pPr algn="l"/>
             <a:r>
-              <a:rPr sz="1400" b="1">
+              <a:rPr sz="1300" b="1">
                 <a:solidFill>
                   <a:srgbClr val="1B3A4B"/>
                 </a:solidFill>
                 <a:latin typeface="Calibri"/>
               </a:rPr>
-              <a:t>Ingest &amp; EDA</a:t>
+              <a:t>Ingest &amp; EDA (done)</a:t>
             </a:r>
           </a:p>
         </p:txBody>
@@ -3488,8 +3488,8 @@
         </p:nvSpPr>
         <p:spPr>
           <a:xfrm>
-            <a:off x="457200" y="2148840"/>
-            <a:ext cx="2468880" cy="1463040"/>
+            <a:off x="429768" y="2176272"/>
+            <a:ext cx="2514600" cy="1417320"/>
           </a:xfrm>
           <a:prstGeom prst="rect">
             <a:avLst/>
@@ -3504,45 +3504,45 @@
           <a:p>
             <a:pPr algn="l"/>
             <a:r>
-              <a:rPr sz="1200" b="0">
+              <a:rPr sz="1100" b="0">
                 <a:solidFill>
                   <a:srgbClr val="5C6B73"/>
                 </a:solidFill>
                 <a:latin typeface="Calibri"/>
               </a:rPr>
-              <a:t>•  Repo + pipeline setup</a:t>
+              <a:t>•  Repo + active cohort (K≥5)</a:t>
             </a:r>
           </a:p>
           <a:p>
             <a:pPr>
               <a:spcBef>
-                <a:spcPts val="600"/>
+                <a:spcPts val="500"/>
               </a:spcBef>
             </a:pPr>
             <a:r>
-              <a:rPr sz="1200" b="0">
+              <a:rPr sz="1100" b="0">
                 <a:solidFill>
                   <a:srgbClr val="5C6B73"/>
                 </a:solidFill>
                 <a:latin typeface="Calibri"/>
               </a:rPr>
-              <a:t>•  Active-user cohort</a:t>
+              <a:t>•  Cart→purchase signal EDA</a:t>
             </a:r>
           </a:p>
           <a:p>
             <a:pPr>
               <a:spcBef>
-                <a:spcPts val="600"/>
+                <a:spcPts val="500"/>
               </a:spcBef>
             </a:pPr>
             <a:r>
-              <a:rPr sz="1200" b="0">
+              <a:rPr sz="1100" b="0">
                 <a:solidFill>
                   <a:srgbClr val="5C6B73"/>
                 </a:solidFill>
                 <a:latin typeface="Calibri"/>
               </a:rPr>
-              <a:t>•  Preliminary EDA report</a:t>
+              <a:t>•  Item/category EDA + explor. clusters</a:t>
             </a:r>
           </a:p>
         </p:txBody>
@@ -3555,7 +3555,7 @@
         </p:nvSpPr>
         <p:spPr>
           <a:xfrm>
-            <a:off x="3200400" y="1188720"/>
+            <a:off x="3200400" y="1170432"/>
             <a:ext cx="2697480" cy="2606040"/>
           </a:xfrm>
           <a:prstGeom prst="roundRect">
@@ -3600,14 +3600,14 @@
         </p:nvSpPr>
         <p:spPr>
           <a:xfrm>
-            <a:off x="3200400" y="1188720"/>
+            <a:off x="3200400" y="1170432"/>
             <a:ext cx="2697480" cy="502920"/>
           </a:xfrm>
           <a:prstGeom prst="rect">
             <a:avLst/>
           </a:prstGeom>
           <a:solidFill>
-            <a:srgbClr val="3D8BA8"/>
+            <a:srgbClr val="2A6F97"/>
           </a:solidFill>
           <a:ln>
             <a:noFill/>
@@ -3643,8 +3643,8 @@
         </p:nvSpPr>
         <p:spPr>
           <a:xfrm>
-            <a:off x="3337560" y="1261872"/>
-            <a:ext cx="1645920" cy="228600"/>
+            <a:off x="3310128" y="1243584"/>
+            <a:ext cx="1737360" cy="228600"/>
           </a:xfrm>
           <a:prstGeom prst="rect">
             <a:avLst/>
@@ -3659,7 +3659,7 @@
           <a:p>
             <a:pPr algn="l"/>
             <a:r>
-              <a:rPr sz="1400" b="1">
+              <a:rPr sz="1300" b="1">
                 <a:solidFill>
                   <a:srgbClr val="FFFFFF"/>
                 </a:solidFill>
@@ -3678,8 +3678,8 @@
         </p:nvSpPr>
         <p:spPr>
           <a:xfrm>
-            <a:off x="4663440" y="1280160"/>
-            <a:ext cx="1097280" cy="228600"/>
+            <a:off x="4617720" y="1261872"/>
+            <a:ext cx="1143000" cy="228600"/>
           </a:xfrm>
           <a:prstGeom prst="rect">
             <a:avLst/>
@@ -3713,8 +3713,8 @@
         </p:nvSpPr>
         <p:spPr>
           <a:xfrm>
-            <a:off x="3337560" y="1783080"/>
-            <a:ext cx="2468880" cy="320040"/>
+            <a:off x="3310128" y="1764792"/>
+            <a:ext cx="2514600" cy="365760"/>
           </a:xfrm>
           <a:prstGeom prst="rect">
             <a:avLst/>
@@ -3729,13 +3729,13 @@
           <a:p>
             <a:pPr algn="l"/>
             <a:r>
-              <a:rPr sz="1400" b="1">
+              <a:rPr sz="1300" b="1">
                 <a:solidFill>
                   <a:srgbClr val="1B3A4B"/>
                 </a:solidFill>
                 <a:latin typeface="Calibri"/>
               </a:rPr>
-              <a:t>Baselines</a:t>
+              <a:t>Baselines (next)</a:t>
             </a:r>
           </a:p>
         </p:txBody>
@@ -3748,8 +3748,8 @@
         </p:nvSpPr>
         <p:spPr>
           <a:xfrm>
-            <a:off x="3337560" y="2148840"/>
-            <a:ext cx="2468880" cy="1463040"/>
+            <a:off x="3310128" y="2176272"/>
+            <a:ext cx="2514600" cy="1417320"/>
           </a:xfrm>
           <a:prstGeom prst="rect">
             <a:avLst/>
@@ -3764,23 +3764,23 @@
           <a:p>
             <a:pPr algn="l"/>
             <a:r>
-              <a:rPr sz="1200" b="0">
+              <a:rPr sz="1100" b="0">
                 <a:solidFill>
                   <a:srgbClr val="5C6B73"/>
                 </a:solidFill>
                 <a:latin typeface="Calibri"/>
               </a:rPr>
-              <a:t>•  Category clustering</a:t>
+              <a:t>•  Temporal train/val/test split</a:t>
             </a:r>
           </a:p>
           <a:p>
             <a:pPr>
               <a:spcBef>
-                <a:spcPts val="600"/>
+                <a:spcPts val="500"/>
               </a:spcBef>
             </a:pPr>
             <a:r>
-              <a:rPr sz="1200" b="0">
+              <a:rPr sz="1100" b="0">
                 <a:solidFill>
                   <a:srgbClr val="5C6B73"/>
                 </a:solidFill>
@@ -3792,17 +3792,17 @@
           <a:p>
             <a:pPr>
               <a:spcBef>
-                <a:spcPts val="600"/>
+                <a:spcPts val="500"/>
               </a:spcBef>
             </a:pPr>
             <a:r>
-              <a:rPr sz="1200" b="0">
+              <a:rPr sz="1100" b="0">
                 <a:solidFill>
                   <a:srgbClr val="5C6B73"/>
                 </a:solidFill>
                 <a:latin typeface="Calibri"/>
               </a:rPr>
-              <a:t>•  Eval pipeline + temporal split</a:t>
+              <a:t>•  Benchmark table (purchase-only)</a:t>
             </a:r>
           </a:p>
         </p:txBody>
@@ -3815,7 +3815,7 @@
         </p:nvSpPr>
         <p:spPr>
           <a:xfrm>
-            <a:off x="6080760" y="1188720"/>
+            <a:off x="6080760" y="1170432"/>
             <a:ext cx="2697480" cy="2606040"/>
           </a:xfrm>
           <a:prstGeom prst="roundRect">
@@ -3860,7 +3860,7 @@
         </p:nvSpPr>
         <p:spPr>
           <a:xfrm>
-            <a:off x="6080760" y="1188720"/>
+            <a:off x="6080760" y="1170432"/>
             <a:ext cx="2697480" cy="502920"/>
           </a:xfrm>
           <a:prstGeom prst="rect">
@@ -3903,8 +3903,8 @@
         </p:nvSpPr>
         <p:spPr>
           <a:xfrm>
-            <a:off x="6217920" y="1261872"/>
-            <a:ext cx="1645920" cy="228600"/>
+            <a:off x="6190488" y="1243584"/>
+            <a:ext cx="1737360" cy="228600"/>
           </a:xfrm>
           <a:prstGeom prst="rect">
             <a:avLst/>
@@ -3919,7 +3919,7 @@
           <a:p>
             <a:pPr algn="l"/>
             <a:r>
-              <a:rPr sz="1400" b="1">
+              <a:rPr sz="1300" b="1">
                 <a:solidFill>
                   <a:srgbClr val="FFFFFF"/>
                 </a:solidFill>
@@ -3938,8 +3938,8 @@
         </p:nvSpPr>
         <p:spPr>
           <a:xfrm>
-            <a:off x="7543800" y="1280160"/>
-            <a:ext cx="1097280" cy="228600"/>
+            <a:off x="7498080" y="1261872"/>
+            <a:ext cx="1143000" cy="228600"/>
           </a:xfrm>
           <a:prstGeom prst="rect">
             <a:avLst/>
@@ -3973,8 +3973,8 @@
         </p:nvSpPr>
         <p:spPr>
           <a:xfrm>
-            <a:off x="6217920" y="1783080"/>
-            <a:ext cx="2468880" cy="320040"/>
+            <a:off x="6190488" y="1764792"/>
+            <a:ext cx="2514600" cy="365760"/>
           </a:xfrm>
           <a:prstGeom prst="rect">
             <a:avLst/>
@@ -3989,13 +3989,13 @@
           <a:p>
             <a:pPr algn="l"/>
             <a:r>
-              <a:rPr sz="1400" b="1">
+              <a:rPr sz="1300" b="1">
                 <a:solidFill>
                   <a:srgbClr val="1B3A4B"/>
                 </a:solidFill>
                 <a:latin typeface="Calibri"/>
               </a:rPr>
-              <a:t>Cart-aware models</a:t>
+              <a:t>Cart- &amp; category-aware</a:t>
             </a:r>
           </a:p>
         </p:txBody>
@@ -4008,8 +4008,8 @@
         </p:nvSpPr>
         <p:spPr>
           <a:xfrm>
-            <a:off x="6217920" y="2148840"/>
-            <a:ext cx="2468880" cy="1463040"/>
+            <a:off x="6190488" y="2176272"/>
+            <a:ext cx="2514600" cy="1417320"/>
           </a:xfrm>
           <a:prstGeom prst="rect">
             <a:avLst/>
@@ -4024,45 +4024,45 @@
           <a:p>
             <a:pPr algn="l"/>
             <a:r>
-              <a:rPr sz="1200" b="0">
+              <a:rPr sz="1100" b="0">
                 <a:solidFill>
                   <a:srgbClr val="5C6B73"/>
                 </a:solidFill>
                 <a:latin typeface="Calibri"/>
               </a:rPr>
-              <a:t>•  Cart-augmented sequences</a:t>
+              <a:t>•  Cart-augmented SASRec</a:t>
             </a:r>
           </a:p>
           <a:p>
             <a:pPr>
               <a:spcBef>
-                <a:spcPts val="600"/>
+                <a:spcPts val="500"/>
               </a:spcBef>
             </a:pPr>
             <a:r>
-              <a:rPr sz="1200" b="0">
+              <a:rPr sz="1100" b="0">
                 <a:solidFill>
                   <a:srgbClr val="5C6B73"/>
                 </a:solidFill>
                 <a:latin typeface="Calibri"/>
               </a:rPr>
-              <a:t>•  Retrain SASRec</a:t>
+              <a:t>•  Category embeddings / conditioning</a:t>
             </a:r>
           </a:p>
           <a:p>
             <a:pPr>
               <a:spcBef>
-                <a:spcPts val="600"/>
+                <a:spcPts val="500"/>
               </a:spcBef>
             </a:pPr>
             <a:r>
-              <a:rPr sz="1200" b="0">
+              <a:rPr sz="1100" b="0">
                 <a:solidFill>
                   <a:srgbClr val="5C6B73"/>
                 </a:solidFill>
                 <a:latin typeface="Calibri"/>
               </a:rPr>
-              <a:t>•  Category-conditioned variant</a:t>
+              <a:t>•  Train-only category features if used</a:t>
             </a:r>
           </a:p>
         </p:txBody>
@@ -4075,7 +4075,7 @@
         </p:nvSpPr>
         <p:spPr>
           <a:xfrm>
-            <a:off x="8961120" y="1188720"/>
+            <a:off x="8961120" y="1170432"/>
             <a:ext cx="2697480" cy="2606040"/>
           </a:xfrm>
           <a:prstGeom prst="roundRect">
@@ -4120,7 +4120,7 @@
         </p:nvSpPr>
         <p:spPr>
           <a:xfrm>
-            <a:off x="8961120" y="1188720"/>
+            <a:off x="8961120" y="1170432"/>
             <a:ext cx="2697480" cy="502920"/>
           </a:xfrm>
           <a:prstGeom prst="rect">
@@ -4163,8 +4163,8 @@
         </p:nvSpPr>
         <p:spPr>
           <a:xfrm>
-            <a:off x="9098280" y="1261872"/>
-            <a:ext cx="1645920" cy="228600"/>
+            <a:off x="9070848" y="1243584"/>
+            <a:ext cx="1737360" cy="228600"/>
           </a:xfrm>
           <a:prstGeom prst="rect">
             <a:avLst/>
@@ -4179,7 +4179,7 @@
           <a:p>
             <a:pPr algn="l"/>
             <a:r>
-              <a:rPr sz="1400" b="1">
+              <a:rPr sz="1300" b="1">
                 <a:solidFill>
                   <a:srgbClr val="FFFFFF"/>
                 </a:solidFill>
@@ -4198,8 +4198,8 @@
         </p:nvSpPr>
         <p:spPr>
           <a:xfrm>
-            <a:off x="10424160" y="1280160"/>
-            <a:ext cx="1097280" cy="228600"/>
+            <a:off x="10378440" y="1261872"/>
+            <a:ext cx="1143000" cy="228600"/>
           </a:xfrm>
           <a:prstGeom prst="rect">
             <a:avLst/>
@@ -4233,8 +4233,8 @@
         </p:nvSpPr>
         <p:spPr>
           <a:xfrm>
-            <a:off x="9098280" y="1783080"/>
-            <a:ext cx="2468880" cy="320040"/>
+            <a:off x="9070848" y="1764792"/>
+            <a:ext cx="2514600" cy="365760"/>
           </a:xfrm>
           <a:prstGeom prst="rect">
             <a:avLst/>
@@ -4249,7 +4249,7 @@
           <a:p>
             <a:pPr algn="l"/>
             <a:r>
-              <a:rPr sz="1400" b="1">
+              <a:rPr sz="1300" b="1">
                 <a:solidFill>
                   <a:srgbClr val="1B3A4B"/>
                 </a:solidFill>
@@ -4268,8 +4268,8 @@
         </p:nvSpPr>
         <p:spPr>
           <a:xfrm>
-            <a:off x="9098280" y="2148840"/>
-            <a:ext cx="2468880" cy="1463040"/>
+            <a:off x="9070848" y="2176272"/>
+            <a:ext cx="2514600" cy="1417320"/>
           </a:xfrm>
           <a:prstGeom prst="rect">
             <a:avLst/>
@@ -4284,7 +4284,7 @@
           <a:p>
             <a:pPr algn="l"/>
             <a:r>
-              <a:rPr sz="1200" b="0">
+              <a:rPr sz="1100" b="0">
                 <a:solidFill>
                   <a:srgbClr val="5C6B73"/>
                 </a:solidFill>
@@ -4296,33 +4296,33 @@
           <a:p>
             <a:pPr>
               <a:spcBef>
-                <a:spcPts val="600"/>
+                <a:spcPts val="500"/>
               </a:spcBef>
             </a:pPr>
             <a:r>
-              <a:rPr sz="1200" b="0">
+              <a:rPr sz="1100" b="0">
                 <a:solidFill>
                   <a:srgbClr val="5C6B73"/>
                 </a:solidFill>
                 <a:latin typeface="Calibri"/>
               </a:rPr>
-              <a:t>•  Ablation + final report</a:t>
+              <a:t>•  Stratified eval + ablation</a:t>
             </a:r>
           </a:p>
           <a:p>
             <a:pPr>
               <a:spcBef>
-                <a:spcPts val="600"/>
+                <a:spcPts val="500"/>
               </a:spcBef>
             </a:pPr>
             <a:r>
-              <a:rPr sz="1200" b="0">
+              <a:rPr sz="1100" b="0">
                 <a:solidFill>
                   <a:srgbClr val="5C6B73"/>
                 </a:solidFill>
                 <a:latin typeface="Calibri"/>
               </a:rPr>
-              <a:t>•  Slides + public GitHub</a:t>
+              <a:t>•  Report, slides, public GitHub</a:t>
             </a:r>
           </a:p>
         </p:txBody>
@@ -4423,8 +4423,8 @@
         </p:nvSpPr>
         <p:spPr>
           <a:xfrm>
-            <a:off x="594360" y="4114799"/>
-            <a:ext cx="10972800" cy="320040"/>
+            <a:off x="594360" y="4087367"/>
+            <a:ext cx="10972800" cy="274320"/>
           </a:xfrm>
           <a:prstGeom prst="rect">
             <a:avLst/>
@@ -4439,13 +4439,13 @@
           <a:p>
             <a:pPr algn="l"/>
             <a:r>
-              <a:rPr sz="1600" b="1">
+              <a:rPr sz="1500" b="1">
                 <a:solidFill>
                   <a:srgbClr val="1B3A4B"/>
                 </a:solidFill>
                 <a:latin typeface="Calibri"/>
               </a:rPr>
-              <a:t>Risks &amp; Mitigations</a:t>
+              <a:t>Risks &amp; Mitigations  (updated with EDA evidence)</a:t>
             </a:r>
           </a:p>
         </p:txBody>
@@ -4458,8 +4458,8 @@
         </p:nvSpPr>
         <p:spPr>
           <a:xfrm>
-            <a:off x="594360" y="4480559"/>
-            <a:ext cx="5303520" cy="914400"/>
+            <a:off x="594360" y="4434839"/>
+            <a:ext cx="5303520" cy="960120"/>
           </a:xfrm>
           <a:prstGeom prst="rect">
             <a:avLst/>
@@ -4474,29 +4474,13 @@
           <a:p>
             <a:pPr algn="l"/>
             <a:r>
-              <a:rPr sz="1300" b="1">
+              <a:rPr sz="1200" b="1">
                 <a:solidFill>
                   <a:srgbClr val="BC4749"/>
                 </a:solidFill>
                 <a:latin typeface="Calibri"/>
               </a:rPr>
               <a:t>⚠  Anonymized categories</a:t>
-            </a:r>
-          </a:p>
-          <a:p>
-            <a:pPr>
-              <a:spcBef>
-                <a:spcPts val="300"/>
-              </a:spcBef>
-            </a:pPr>
-            <a:r>
-              <a:rPr sz="1100" b="0">
-                <a:solidFill>
-                  <a:srgbClr val="5C6B73"/>
-                </a:solidFill>
-                <a:latin typeface="Calibri"/>
-              </a:rPr>
-              <a:t>Risk: No human-readable labels → harder to interpret category effects</a:t>
             </a:r>
           </a:p>
           <a:p>
@@ -4506,64 +4490,13 @@
               </a:spcBef>
             </a:pPr>
             <a:r>
-              <a:rPr sz="1100" b="0">
-                <a:solidFill>
-                  <a:srgbClr val="1B3A4B"/>
+              <a:rPr sz="1000" b="0">
+                <a:solidFill>
+                  <a:srgbClr val="5C6B73"/>
                 </a:solidFill>
                 <a:latin typeface="Calibri"/>
               </a:rPr>
-              <a:t>Mitigation: Report results as anonymized groups; avoid overclaiming semantics</a:t>
-            </a:r>
-          </a:p>
-        </p:txBody>
-      </p:sp>
-      <p:sp>
-        <p:nvSpPr>
-          <p:cNvPr id="35" name="TextBox 34"/>
-          <p:cNvSpPr txBox="1"/>
-          <p:nvPr/>
-        </p:nvSpPr>
-        <p:spPr>
-          <a:xfrm>
-            <a:off x="6263640" y="4480559"/>
-            <a:ext cx="5303520" cy="914400"/>
-          </a:xfrm>
-          <a:prstGeom prst="rect">
-            <a:avLst/>
-          </a:prstGeom>
-          <a:noFill/>
-        </p:spPr>
-        <p:txBody>
-          <a:bodyPr wrap="square">
-            <a:spAutoFit/>
-          </a:bodyPr>
-          <a:lstStyle/>
-          <a:p>
-            <a:pPr algn="l"/>
-            <a:r>
-              <a:rPr sz="1300" b="1">
-                <a:solidFill>
-                  <a:srgbClr val="BC4749"/>
-                </a:solidFill>
-                <a:latin typeface="Calibri"/>
-              </a:rPr>
-              <a:t>⚠  Scale / compute</a:t>
-            </a:r>
-          </a:p>
-          <a:p>
-            <a:pPr>
-              <a:spcBef>
-                <a:spcPts val="300"/>
-              </a:spcBef>
-            </a:pPr>
-            <a:r>
-              <a:rPr sz="1100" b="0">
-                <a:solidFill>
-                  <a:srgbClr val="5C6B73"/>
-                </a:solidFill>
-                <a:latin typeface="Calibri"/>
-              </a:rPr>
-              <a:t>Risk: Full logs are huge for sequence build + training</a:t>
+              <a:t>Still no readable labels — cannot name product types from clusters</a:t>
             </a:r>
           </a:p>
           <a:p>
@@ -4573,27 +4506,27 @@
               </a:spcBef>
             </a:pPr>
             <a:r>
-              <a:rPr sz="1100" b="0">
+              <a:rPr sz="1000" b="0">
                 <a:solidFill>
                   <a:srgbClr val="1B3A4B"/>
                 </a:solidFill>
                 <a:latin typeface="Calibri"/>
               </a:rPr>
-              <a:t>Mitigation: Subsample stratified active-user cohort; cache Parquet</a:t>
-            </a:r>
-          </a:p>
-        </p:txBody>
-      </p:sp>
-      <p:sp>
-        <p:nvSpPr>
-          <p:cNvPr id="36" name="TextBox 35"/>
+              <a:t>EDA: categories differ in cart intensity (soft k=2). Report anonymized groups only</a:t>
+            </a:r>
+          </a:p>
+        </p:txBody>
+      </p:sp>
+      <p:sp>
+        <p:nvSpPr>
+          <p:cNvPr id="35" name="TextBox 34"/>
           <p:cNvSpPr txBox="1"/>
           <p:nvPr/>
         </p:nvSpPr>
         <p:spPr>
           <a:xfrm>
-            <a:off x="594360" y="5486399"/>
-            <a:ext cx="5303520" cy="914400"/>
+            <a:off x="6263640" y="4434839"/>
+            <a:ext cx="5303520" cy="960120"/>
           </a:xfrm>
           <a:prstGeom prst="rect">
             <a:avLst/>
@@ -4608,29 +4541,13 @@
           <a:p>
             <a:pPr algn="l"/>
             <a:r>
-              <a:rPr sz="1300" b="1">
+              <a:rPr sz="1200" b="1">
                 <a:solidFill>
                   <a:srgbClr val="BC4749"/>
                 </a:solidFill>
                 <a:latin typeface="Calibri"/>
               </a:rPr>
-              <a:t>⚠  Purchase sparsity</a:t>
-            </a:r>
-          </a:p>
-          <a:p>
-            <a:pPr>
-              <a:spcBef>
-                <a:spcPts val="300"/>
-              </a:spcBef>
-            </a:pPr>
-            <a:r>
-              <a:rPr sz="1100" b="0">
-                <a:solidFill>
-                  <a:srgbClr val="5C6B73"/>
-                </a:solidFill>
-                <a:latin typeface="Calibri"/>
-              </a:rPr>
-              <a:t>Risk: Noisy estimates for rare categories / short histories</a:t>
+              <a:t>⚠  Scale / compute</a:t>
             </a:r>
           </a:p>
           <a:p>
@@ -4640,64 +4557,13 @@
               </a:spcBef>
             </a:pPr>
             <a:r>
-              <a:rPr sz="1100" b="0">
-                <a:solidFill>
-                  <a:srgbClr val="1B3A4B"/>
+              <a:rPr sz="1000" b="0">
+                <a:solidFill>
+                  <a:srgbClr val="5C6B73"/>
                 </a:solidFill>
                 <a:latin typeface="Calibri"/>
               </a:rPr>
-              <a:t>Mitigation: Min activity threshold (K≥5); bootstrap CIs, not point estimates only</a:t>
-            </a:r>
-          </a:p>
-        </p:txBody>
-      </p:sp>
-      <p:sp>
-        <p:nvSpPr>
-          <p:cNvPr id="37" name="TextBox 36"/>
-          <p:cNvSpPr txBox="1"/>
-          <p:nvPr/>
-        </p:nvSpPr>
-        <p:spPr>
-          <a:xfrm>
-            <a:off x="6263640" y="5486399"/>
-            <a:ext cx="5303520" cy="914400"/>
-          </a:xfrm>
-          <a:prstGeom prst="rect">
-            <a:avLst/>
-          </a:prstGeom>
-          <a:noFill/>
-        </p:spPr>
-        <p:txBody>
-          <a:bodyPr wrap="square">
-            <a:spAutoFit/>
-          </a:bodyPr>
-          <a:lstStyle/>
-          <a:p>
-            <a:pPr algn="l"/>
-            <a:r>
-              <a:rPr sz="1300" b="1">
-                <a:solidFill>
-                  <a:srgbClr val="BC4749"/>
-                </a:solidFill>
-                <a:latin typeface="Calibri"/>
-              </a:rPr>
-              <a:t>⚠  Negative transfer</a:t>
-            </a:r>
-          </a:p>
-          <a:p>
-            <a:pPr>
-              <a:spcBef>
-                <a:spcPts val="300"/>
-              </a:spcBef>
-            </a:pPr>
-            <a:r>
-              <a:rPr sz="1100" b="0">
-                <a:solidFill>
-                  <a:srgbClr val="5C6B73"/>
-                </a:solidFill>
-                <a:latin typeface="Calibri"/>
-              </a:rPr>
-              <a:t>Risk: One global category model may hurt heterogeneous groups</a:t>
+              <a:t>Full logs still too large for sequence training</a:t>
             </a:r>
           </a:p>
           <a:p>
@@ -4707,13 +4573,147 @@
               </a:spcBef>
             </a:pPr>
             <a:r>
-              <a:rPr sz="1100" b="0">
+              <a:rPr sz="1000" b="0">
                 <a:solidFill>
                   <a:srgbClr val="1B3A4B"/>
                 </a:solidFill>
                 <a:latin typeface="Calibri"/>
               </a:rPr>
-              <a:t>Mitigation: Category-stratified evaluation to detect and report transfer risk</a:t>
+              <a:t>Mitigated: active cohort retained ~70% events; cache Parquet; keep candidate pool</a:t>
+            </a:r>
+          </a:p>
+        </p:txBody>
+      </p:sp>
+      <p:sp>
+        <p:nvSpPr>
+          <p:cNvPr id="36" name="TextBox 35"/>
+          <p:cNvSpPr txBox="1"/>
+          <p:nvPr/>
+        </p:nvSpPr>
+        <p:spPr>
+          <a:xfrm>
+            <a:off x="594360" y="5440679"/>
+            <a:ext cx="5303520" cy="960120"/>
+          </a:xfrm>
+          <a:prstGeom prst="rect">
+            <a:avLst/>
+          </a:prstGeom>
+          <a:noFill/>
+        </p:spPr>
+        <p:txBody>
+          <a:bodyPr wrap="square">
+            <a:spAutoFit/>
+          </a:bodyPr>
+          <a:lstStyle/>
+          <a:p>
+            <a:pPr algn="l"/>
+            <a:r>
+              <a:rPr sz="1200" b="1">
+                <a:solidFill>
+                  <a:srgbClr val="BC4749"/>
+                </a:solidFill>
+                <a:latin typeface="Calibri"/>
+              </a:rPr>
+              <a:t>⚠  Purchase sparsity</a:t>
+            </a:r>
+          </a:p>
+          <a:p>
+            <a:pPr>
+              <a:spcBef>
+                <a:spcPts val="200"/>
+              </a:spcBef>
+            </a:pPr>
+            <a:r>
+              <a:rPr sz="1000" b="0">
+                <a:solidFill>
+                  <a:srgbClr val="5C6B73"/>
+                </a:solidFill>
+                <a:latin typeface="Calibri"/>
+              </a:rPr>
+              <a:t>Short histories / rare categories → noisy estimates</a:t>
+            </a:r>
+          </a:p>
+          <a:p>
+            <a:pPr>
+              <a:spcBef>
+                <a:spcPts val="200"/>
+              </a:spcBef>
+            </a:pPr>
+            <a:r>
+              <a:rPr sz="1000" b="0">
+                <a:solidFill>
+                  <a:srgbClr val="1B3A4B"/>
+                </a:solidFill>
+                <a:latin typeface="Calibri"/>
+              </a:rPr>
+              <a:t>Mitigated: K≥5 cohort; top-SKU candidate pool; bootstrap CIs in modeling</a:t>
+            </a:r>
+          </a:p>
+        </p:txBody>
+      </p:sp>
+      <p:sp>
+        <p:nvSpPr>
+          <p:cNvPr id="37" name="TextBox 36"/>
+          <p:cNvSpPr txBox="1"/>
+          <p:nvPr/>
+        </p:nvSpPr>
+        <p:spPr>
+          <a:xfrm>
+            <a:off x="6263640" y="5440679"/>
+            <a:ext cx="5303520" cy="960120"/>
+          </a:xfrm>
+          <a:prstGeom prst="rect">
+            <a:avLst/>
+          </a:prstGeom>
+          <a:noFill/>
+        </p:spPr>
+        <p:txBody>
+          <a:bodyPr wrap="square">
+            <a:spAutoFit/>
+          </a:bodyPr>
+          <a:lstStyle/>
+          <a:p>
+            <a:pPr algn="l"/>
+            <a:r>
+              <a:rPr sz="1200" b="1">
+                <a:solidFill>
+                  <a:srgbClr val="BC4749"/>
+                </a:solidFill>
+                <a:latin typeface="Calibri"/>
+              </a:rPr>
+              <a:t>⚠  Negative transfer</a:t>
+            </a:r>
+          </a:p>
+          <a:p>
+            <a:pPr>
+              <a:spcBef>
+                <a:spcPts val="200"/>
+              </a:spcBef>
+            </a:pPr>
+            <a:r>
+              <a:rPr sz="1000" b="0">
+                <a:solidFill>
+                  <a:srgbClr val="5C6B73"/>
+                </a:solidFill>
+                <a:latin typeface="Calibri"/>
+              </a:rPr>
+              <a:t>Category / cluster conditioning may help some groups, hurt others</a:t>
+            </a:r>
+          </a:p>
+          <a:p>
+            <a:pPr>
+              <a:spcBef>
+                <a:spcPts val="200"/>
+              </a:spcBef>
+            </a:pPr>
+            <a:r>
+              <a:rPr sz="1000" b="0">
+                <a:solidFill>
+                  <a:srgbClr val="1B3A4B"/>
+                </a:solidFill>
+                <a:latin typeface="Calibri"/>
+              </a:rPr>
+              <a:t>Phase 3–4: stratified eval by category/cluster + CIs on metric deltas</a:t>
             </a:r>
           </a:p>
         </p:txBody>

</xml_diff>